<commit_message>
Fixed definition of diameter in BTree notes
</commit_message>
<xml_diff>
--- a/u08a_bTrees/notes/_a - Classifying binary trees and Tree Traversal.pptx
+++ b/u08a_bTrees/notes/_a - Classifying binary trees and Tree Traversal.pptx
@@ -1097,7 +1097,18 @@
           <a:bodyPr/>
           <a:lstStyle/>
           <a:p>
-            <a:endParaRPr lang="en-US"/>
+            <a:r>
+              <a:rPr lang="en-US" dirty="0"/>
+              <a:t>Which is the complement to the number of  parents, the number of children or the number of leaves? The number of leaves, </a:t>
+            </a:r>
+            <a:r>
+              <a:rPr lang="en-US" dirty="0" err="1"/>
+              <a:t>b.c.</a:t>
+            </a:r>
+            <a:r>
+              <a:rPr lang="en-US" dirty="0"/>
+              <a:t> 4 + 5 = 9</a:t>
+            </a:r>
           </a:p>
         </p:txBody>
       </p:sp>
@@ -27787,14 +27798,14 @@
           <a:noFill/>
           <a:extLst>
             <a:ext uri="{909E8E84-426E-40dd-AFC4-6F175D3DCCD1}">
-              <a14:hiddenFill xmlns="" xmlns:a14="http://schemas.microsoft.com/office/drawing/2010/main">
+              <a14:hiddenFill xmlns:a14="http://schemas.microsoft.com/office/drawing/2010/main" xmlns="">
                 <a:solidFill>
                   <a:srgbClr val="FFFFFF"/>
                 </a:solidFill>
               </a14:hiddenFill>
             </a:ext>
             <a:ext uri="{91240B29-F687-4f45-9708-019B960494DF}">
-              <a14:hiddenLine xmlns="" xmlns:a14="http://schemas.microsoft.com/office/drawing/2010/main" w="9525">
+              <a14:hiddenLine xmlns:a14="http://schemas.microsoft.com/office/drawing/2010/main" xmlns="" w="9525">
                 <a:solidFill>
                   <a:srgbClr val="000000"/>
                 </a:solidFill>
@@ -28217,14 +28228,14 @@
               </a:ln>
               <a:extLst>
                 <a:ext uri="{909E8E84-426E-40dd-AFC4-6F175D3DCCD1}">
-                  <a14:hiddenFill xmlns="" xmlns:a14="http://schemas.microsoft.com/office/drawing/2010/main">
+                  <a14:hiddenFill xmlns:a14="http://schemas.microsoft.com/office/drawing/2010/main" xmlns="">
                     <a:solidFill>
                       <a:srgbClr val="FFFFFF"/>
                     </a:solidFill>
                   </a14:hiddenFill>
                 </a:ext>
                 <a:ext uri="{91240B29-F687-4f45-9708-019B960494DF}">
-                  <a14:hiddenLine xmlns="" xmlns:a14="http://schemas.microsoft.com/office/drawing/2010/main" w="9525">
+                  <a14:hiddenLine xmlns:a14="http://schemas.microsoft.com/office/drawing/2010/main" xmlns="" w="9525">
                     <a:solidFill>
                       <a:srgbClr val="000000"/>
                     </a:solidFill>
@@ -28452,14 +28463,14 @@
               </a:ln>
               <a:extLst>
                 <a:ext uri="{909E8E84-426E-40dd-AFC4-6F175D3DCCD1}">
-                  <a14:hiddenFill xmlns="" xmlns:a14="http://schemas.microsoft.com/office/drawing/2010/main">
+                  <a14:hiddenFill xmlns:a14="http://schemas.microsoft.com/office/drawing/2010/main" xmlns="">
                     <a:solidFill>
                       <a:srgbClr val="FFFFFF"/>
                     </a:solidFill>
                   </a14:hiddenFill>
                 </a:ext>
                 <a:ext uri="{91240B29-F687-4f45-9708-019B960494DF}">
-                  <a14:hiddenLine xmlns="" xmlns:a14="http://schemas.microsoft.com/office/drawing/2010/main" w="9525">
+                  <a14:hiddenLine xmlns:a14="http://schemas.microsoft.com/office/drawing/2010/main" xmlns="" w="9525">
                     <a:solidFill>
                       <a:srgbClr val="000000"/>
                     </a:solidFill>
@@ -28646,7 +28657,7 @@
               </a:ln>
               <a:extLst>
                 <a:ext uri="{909E8E84-426E-40dd-AFC4-6F175D3DCCD1}">
-                  <a14:hiddenFill xmlns="" xmlns:a14="http://schemas.microsoft.com/office/drawing/2010/main">
+                  <a14:hiddenFill xmlns:a14="http://schemas.microsoft.com/office/drawing/2010/main" xmlns="">
                     <a:solidFill>
                       <a:srgbClr val="FFFFFF"/>
                     </a:solidFill>
@@ -28805,7 +28816,7 @@
               </a:ln>
               <a:extLst>
                 <a:ext uri="{909E8E84-426E-40dd-AFC4-6F175D3DCCD1}">
-                  <a14:hiddenFill xmlns="" xmlns:a14="http://schemas.microsoft.com/office/drawing/2010/main">
+                  <a14:hiddenFill xmlns:a14="http://schemas.microsoft.com/office/drawing/2010/main" xmlns="">
                     <a:solidFill>
                       <a:srgbClr val="FFFFFF"/>
                     </a:solidFill>
@@ -28964,7 +28975,7 @@
               </a:ln>
               <a:extLst>
                 <a:ext uri="{909E8E84-426E-40dd-AFC4-6F175D3DCCD1}">
-                  <a14:hiddenFill xmlns="" xmlns:a14="http://schemas.microsoft.com/office/drawing/2010/main">
+                  <a14:hiddenFill xmlns:a14="http://schemas.microsoft.com/office/drawing/2010/main" xmlns="">
                     <a:solidFill>
                       <a:srgbClr val="FFFFFF"/>
                     </a:solidFill>
@@ -29118,14 +29129,14 @@
               </a:ln>
               <a:extLst>
                 <a:ext uri="{909E8E84-426E-40dd-AFC4-6F175D3DCCD1}">
-                  <a14:hiddenFill xmlns="" xmlns:a14="http://schemas.microsoft.com/office/drawing/2010/main">
+                  <a14:hiddenFill xmlns:a14="http://schemas.microsoft.com/office/drawing/2010/main" xmlns="">
                     <a:solidFill>
                       <a:srgbClr val="FFFFFF"/>
                     </a:solidFill>
                   </a14:hiddenFill>
                 </a:ext>
                 <a:ext uri="{91240B29-F687-4f45-9708-019B960494DF}">
-                  <a14:hiddenLine xmlns="" xmlns:a14="http://schemas.microsoft.com/office/drawing/2010/main" w="12700">
+                  <a14:hiddenLine xmlns:a14="http://schemas.microsoft.com/office/drawing/2010/main" xmlns="" w="12700">
                     <a:solidFill>
                       <a:srgbClr val="000000"/>
                     </a:solidFill>
@@ -29293,14 +29304,14 @@
               </a:ln>
               <a:extLst>
                 <a:ext uri="{909E8E84-426E-40dd-AFC4-6F175D3DCCD1}">
-                  <a14:hiddenFill xmlns="" xmlns:a14="http://schemas.microsoft.com/office/drawing/2010/main">
+                  <a14:hiddenFill xmlns:a14="http://schemas.microsoft.com/office/drawing/2010/main" xmlns="">
                     <a:solidFill>
                       <a:srgbClr val="FFFFFF"/>
                     </a:solidFill>
                   </a14:hiddenFill>
                 </a:ext>
                 <a:ext uri="{91240B29-F687-4f45-9708-019B960494DF}">
-                  <a14:hiddenLine xmlns="" xmlns:a14="http://schemas.microsoft.com/office/drawing/2010/main" w="12700">
+                  <a14:hiddenLine xmlns:a14="http://schemas.microsoft.com/office/drawing/2010/main" xmlns="" w="12700">
                     <a:solidFill>
                       <a:srgbClr val="000000"/>
                     </a:solidFill>
@@ -29468,14 +29479,14 @@
               </a:ln>
               <a:extLst>
                 <a:ext uri="{909E8E84-426E-40dd-AFC4-6F175D3DCCD1}">
-                  <a14:hiddenFill xmlns="" xmlns:a14="http://schemas.microsoft.com/office/drawing/2010/main">
+                  <a14:hiddenFill xmlns:a14="http://schemas.microsoft.com/office/drawing/2010/main" xmlns="">
                     <a:solidFill>
                       <a:srgbClr val="FFFFFF"/>
                     </a:solidFill>
                   </a14:hiddenFill>
                 </a:ext>
                 <a:ext uri="{91240B29-F687-4f45-9708-019B960494DF}">
-                  <a14:hiddenLine xmlns="" xmlns:a14="http://schemas.microsoft.com/office/drawing/2010/main" w="12700">
+                  <a14:hiddenLine xmlns:a14="http://schemas.microsoft.com/office/drawing/2010/main" xmlns="" w="12700">
                     <a:solidFill>
                       <a:srgbClr val="000000"/>
                     </a:solidFill>
@@ -29648,7 +29659,7 @@
               </a:ln>
               <a:extLst>
                 <a:ext uri="{909E8E84-426E-40dd-AFC4-6F175D3DCCD1}">
-                  <a14:hiddenFill xmlns="" xmlns:a14="http://schemas.microsoft.com/office/drawing/2010/main">
+                  <a14:hiddenFill xmlns:a14="http://schemas.microsoft.com/office/drawing/2010/main" xmlns="">
                     <a:noFill/>
                   </a14:hiddenFill>
                 </a:ext>
@@ -29689,7 +29700,7 @@
               </a:ln>
               <a:extLst>
                 <a:ext uri="{909E8E84-426E-40dd-AFC4-6F175D3DCCD1}">
-                  <a14:hiddenFill xmlns="" xmlns:a14="http://schemas.microsoft.com/office/drawing/2010/main">
+                  <a14:hiddenFill xmlns:a14="http://schemas.microsoft.com/office/drawing/2010/main" xmlns="">
                     <a:noFill/>
                   </a14:hiddenFill>
                 </a:ext>
@@ -29730,7 +29741,7 @@
               </a:ln>
               <a:extLst>
                 <a:ext uri="{909E8E84-426E-40dd-AFC4-6F175D3DCCD1}">
-                  <a14:hiddenFill xmlns="" xmlns:a14="http://schemas.microsoft.com/office/drawing/2010/main">
+                  <a14:hiddenFill xmlns:a14="http://schemas.microsoft.com/office/drawing/2010/main" xmlns="">
                     <a:solidFill>
                       <a:srgbClr val="FFFFFF"/>
                     </a:solidFill>
@@ -29889,7 +29900,7 @@
               </a:ln>
               <a:extLst>
                 <a:ext uri="{909E8E84-426E-40dd-AFC4-6F175D3DCCD1}">
-                  <a14:hiddenFill xmlns="" xmlns:a14="http://schemas.microsoft.com/office/drawing/2010/main">
+                  <a14:hiddenFill xmlns:a14="http://schemas.microsoft.com/office/drawing/2010/main" xmlns="">
                     <a:solidFill>
                       <a:srgbClr val="FFFFFF"/>
                     </a:solidFill>
@@ -30048,7 +30059,7 @@
               </a:ln>
               <a:extLst>
                 <a:ext uri="{909E8E84-426E-40dd-AFC4-6F175D3DCCD1}">
-                  <a14:hiddenFill xmlns="" xmlns:a14="http://schemas.microsoft.com/office/drawing/2010/main">
+                  <a14:hiddenFill xmlns:a14="http://schemas.microsoft.com/office/drawing/2010/main" xmlns="">
                     <a:solidFill>
                       <a:srgbClr val="FFFFFF"/>
                     </a:solidFill>
@@ -30202,14 +30213,14 @@
               </a:ln>
               <a:extLst>
                 <a:ext uri="{909E8E84-426E-40dd-AFC4-6F175D3DCCD1}">
-                  <a14:hiddenFill xmlns="" xmlns:a14="http://schemas.microsoft.com/office/drawing/2010/main">
+                  <a14:hiddenFill xmlns:a14="http://schemas.microsoft.com/office/drawing/2010/main" xmlns="">
                     <a:solidFill>
                       <a:srgbClr val="FFFFFF"/>
                     </a:solidFill>
                   </a14:hiddenFill>
                 </a:ext>
                 <a:ext uri="{91240B29-F687-4f45-9708-019B960494DF}">
-                  <a14:hiddenLine xmlns="" xmlns:a14="http://schemas.microsoft.com/office/drawing/2010/main" w="12700">
+                  <a14:hiddenLine xmlns:a14="http://schemas.microsoft.com/office/drawing/2010/main" xmlns="" w="12700">
                     <a:solidFill>
                       <a:srgbClr val="000000"/>
                     </a:solidFill>
@@ -30377,14 +30388,14 @@
               </a:ln>
               <a:extLst>
                 <a:ext uri="{909E8E84-426E-40dd-AFC4-6F175D3DCCD1}">
-                  <a14:hiddenFill xmlns="" xmlns:a14="http://schemas.microsoft.com/office/drawing/2010/main">
+                  <a14:hiddenFill xmlns:a14="http://schemas.microsoft.com/office/drawing/2010/main" xmlns="">
                     <a:solidFill>
                       <a:srgbClr val="FFFFFF"/>
                     </a:solidFill>
                   </a14:hiddenFill>
                 </a:ext>
                 <a:ext uri="{91240B29-F687-4f45-9708-019B960494DF}">
-                  <a14:hiddenLine xmlns="" xmlns:a14="http://schemas.microsoft.com/office/drawing/2010/main" w="12700">
+                  <a14:hiddenLine xmlns:a14="http://schemas.microsoft.com/office/drawing/2010/main" xmlns="" w="12700">
                     <a:solidFill>
                       <a:srgbClr val="000000"/>
                     </a:solidFill>
@@ -30557,7 +30568,7 @@
               </a:ln>
               <a:extLst>
                 <a:ext uri="{909E8E84-426E-40dd-AFC4-6F175D3DCCD1}">
-                  <a14:hiddenFill xmlns="" xmlns:a14="http://schemas.microsoft.com/office/drawing/2010/main">
+                  <a14:hiddenFill xmlns:a14="http://schemas.microsoft.com/office/drawing/2010/main" xmlns="">
                     <a:noFill/>
                   </a14:hiddenFill>
                 </a:ext>
@@ -30598,7 +30609,7 @@
               </a:ln>
               <a:extLst>
                 <a:ext uri="{909E8E84-426E-40dd-AFC4-6F175D3DCCD1}">
-                  <a14:hiddenFill xmlns="" xmlns:a14="http://schemas.microsoft.com/office/drawing/2010/main">
+                  <a14:hiddenFill xmlns:a14="http://schemas.microsoft.com/office/drawing/2010/main" xmlns="">
                     <a:noFill/>
                   </a14:hiddenFill>
                 </a:ext>
@@ -30639,7 +30650,7 @@
               </a:ln>
               <a:extLst>
                 <a:ext uri="{909E8E84-426E-40dd-AFC4-6F175D3DCCD1}">
-                  <a14:hiddenFill xmlns="" xmlns:a14="http://schemas.microsoft.com/office/drawing/2010/main">
+                  <a14:hiddenFill xmlns:a14="http://schemas.microsoft.com/office/drawing/2010/main" xmlns="">
                     <a:solidFill>
                       <a:srgbClr val="FFFFFF"/>
                     </a:solidFill>
@@ -30798,7 +30809,7 @@
               </a:ln>
               <a:extLst>
                 <a:ext uri="{909E8E84-426E-40dd-AFC4-6F175D3DCCD1}">
-                  <a14:hiddenFill xmlns="" xmlns:a14="http://schemas.microsoft.com/office/drawing/2010/main">
+                  <a14:hiddenFill xmlns:a14="http://schemas.microsoft.com/office/drawing/2010/main" xmlns="">
                     <a:noFill/>
                   </a14:hiddenFill>
                 </a:ext>
@@ -30839,7 +30850,7 @@
               </a:ln>
               <a:extLst>
                 <a:ext uri="{909E8E84-426E-40dd-AFC4-6F175D3DCCD1}">
-                  <a14:hiddenFill xmlns="" xmlns:a14="http://schemas.microsoft.com/office/drawing/2010/main">
+                  <a14:hiddenFill xmlns:a14="http://schemas.microsoft.com/office/drawing/2010/main" xmlns="">
                     <a:noFill/>
                   </a14:hiddenFill>
                 </a:ext>
@@ -30875,14 +30886,14 @@
               </a:ln>
               <a:extLst>
                 <a:ext uri="{909E8E84-426E-40dd-AFC4-6F175D3DCCD1}">
-                  <a14:hiddenFill xmlns="" xmlns:a14="http://schemas.microsoft.com/office/drawing/2010/main">
+                  <a14:hiddenFill xmlns:a14="http://schemas.microsoft.com/office/drawing/2010/main" xmlns="">
                     <a:solidFill>
                       <a:srgbClr val="FFFFFF"/>
                     </a:solidFill>
                   </a14:hiddenFill>
                 </a:ext>
                 <a:ext uri="{91240B29-F687-4f45-9708-019B960494DF}">
-                  <a14:hiddenLine xmlns="" xmlns:a14="http://schemas.microsoft.com/office/drawing/2010/main" w="12700">
+                  <a14:hiddenLine xmlns:a14="http://schemas.microsoft.com/office/drawing/2010/main" xmlns="" w="12700">
                     <a:solidFill>
                       <a:srgbClr val="000000"/>
                     </a:solidFill>
@@ -31050,14 +31061,14 @@
               </a:ln>
               <a:extLst>
                 <a:ext uri="{909E8E84-426E-40dd-AFC4-6F175D3DCCD1}">
-                  <a14:hiddenFill xmlns="" xmlns:a14="http://schemas.microsoft.com/office/drawing/2010/main">
+                  <a14:hiddenFill xmlns:a14="http://schemas.microsoft.com/office/drawing/2010/main" xmlns="">
                     <a:solidFill>
                       <a:srgbClr val="FFFFFF"/>
                     </a:solidFill>
                   </a14:hiddenFill>
                 </a:ext>
                 <a:ext uri="{91240B29-F687-4f45-9708-019B960494DF}">
-                  <a14:hiddenLine xmlns="" xmlns:a14="http://schemas.microsoft.com/office/drawing/2010/main" w="12700">
+                  <a14:hiddenLine xmlns:a14="http://schemas.microsoft.com/office/drawing/2010/main" xmlns="" w="12700">
                     <a:solidFill>
                       <a:srgbClr val="000000"/>
                     </a:solidFill>

</xml_diff>

<commit_message>
Updated 1st bTree ppt
</commit_message>
<xml_diff>
--- a/u08a_bTrees/notes/_a - Classifying binary trees and Tree Traversal.pptx
+++ b/u08a_bTrees/notes/_a - Classifying binary trees and Tree Traversal.pptx
@@ -2786,10 +2786,10 @@
           </a:ln>
           <a:extLst>
             <a:ext uri="{FAA26D3D-D897-4be2-8F04-BA451C77F1D7}">
-              <ma14:placeholderFlag xmlns:ma14="http://schemas.microsoft.com/office/mac/drawingml/2011/main" xmlns="" val="1"/>
+              <ma14:placeholderFlag xmlns="" xmlns:ma14="http://schemas.microsoft.com/office/mac/drawingml/2011/main" val="1"/>
             </a:ext>
             <a:ext uri="{909E8E84-426E-40dd-AFC4-6F175D3DCCD1}">
-              <a14:hiddenFill xmlns="" xmlns:a14="http://schemas.microsoft.com/office/drawing/2010/main">
+              <a14:hiddenFill xmlns:a14="http://schemas.microsoft.com/office/drawing/2010/main" xmlns="">
                 <a:solidFill>
                   <a:srgbClr val="FFFFFF"/>
                 </a:solidFill>
@@ -2812,17 +2812,17 @@
           <a:noFill/>
           <a:extLst>
             <a:ext uri="{FAA26D3D-D897-4be2-8F04-BA451C77F1D7}">
-              <ma14:placeholderFlag xmlns:ma14="http://schemas.microsoft.com/office/mac/drawingml/2011/main" xmlns="" val="1"/>
+              <ma14:placeholderFlag xmlns="" xmlns:ma14="http://schemas.microsoft.com/office/mac/drawingml/2011/main" val="1"/>
             </a:ext>
             <a:ext uri="{909E8E84-426E-40dd-AFC4-6F175D3DCCD1}">
-              <a14:hiddenFill xmlns="" xmlns:a14="http://schemas.microsoft.com/office/drawing/2010/main">
+              <a14:hiddenFill xmlns:a14="http://schemas.microsoft.com/office/drawing/2010/main" xmlns="">
                 <a:solidFill>
                   <a:srgbClr val="FFFFFF"/>
                 </a:solidFill>
               </a14:hiddenFill>
             </a:ext>
             <a:ext uri="{91240B29-F687-4f45-9708-019B960494DF}">
-              <a14:hiddenLine xmlns="" xmlns:a14="http://schemas.microsoft.com/office/drawing/2010/main" w="9525">
+              <a14:hiddenLine xmlns:a14="http://schemas.microsoft.com/office/drawing/2010/main" xmlns="" w="9525">
                 <a:solidFill>
                   <a:srgbClr val="000000"/>
                 </a:solidFill>
@@ -2861,14 +2861,14 @@
           <a:noFill/>
           <a:extLst>
             <a:ext uri="{909E8E84-426E-40dd-AFC4-6F175D3DCCD1}">
-              <a14:hiddenFill xmlns="" xmlns:a14="http://schemas.microsoft.com/office/drawing/2010/main">
+              <a14:hiddenFill xmlns:a14="http://schemas.microsoft.com/office/drawing/2010/main" xmlns="">
                 <a:solidFill>
                   <a:srgbClr val="FFFFFF"/>
                 </a:solidFill>
               </a14:hiddenFill>
             </a:ext>
             <a:ext uri="{91240B29-F687-4f45-9708-019B960494DF}">
-              <a14:hiddenLine xmlns="" xmlns:a14="http://schemas.microsoft.com/office/drawing/2010/main" w="9525">
+              <a14:hiddenLine xmlns:a14="http://schemas.microsoft.com/office/drawing/2010/main" xmlns="" w="9525">
                 <a:solidFill>
                   <a:srgbClr val="000000"/>
                 </a:solidFill>
@@ -3059,10 +3059,10 @@
           </a:ln>
           <a:extLst>
             <a:ext uri="{FAA26D3D-D897-4be2-8F04-BA451C77F1D7}">
-              <ma14:placeholderFlag xmlns:ma14="http://schemas.microsoft.com/office/mac/drawingml/2011/main" xmlns="" val="1"/>
+              <ma14:placeholderFlag xmlns="" xmlns:ma14="http://schemas.microsoft.com/office/mac/drawingml/2011/main" val="1"/>
             </a:ext>
             <a:ext uri="{909E8E84-426E-40dd-AFC4-6F175D3DCCD1}">
-              <a14:hiddenFill xmlns="" xmlns:a14="http://schemas.microsoft.com/office/drawing/2010/main">
+              <a14:hiddenFill xmlns:a14="http://schemas.microsoft.com/office/drawing/2010/main" xmlns="">
                 <a:solidFill>
                   <a:srgbClr val="FFFFFF"/>
                 </a:solidFill>
@@ -3085,17 +3085,17 @@
           <a:noFill/>
           <a:extLst>
             <a:ext uri="{FAA26D3D-D897-4be2-8F04-BA451C77F1D7}">
-              <ma14:placeholderFlag xmlns:ma14="http://schemas.microsoft.com/office/mac/drawingml/2011/main" xmlns="" val="1"/>
+              <ma14:placeholderFlag xmlns="" xmlns:ma14="http://schemas.microsoft.com/office/mac/drawingml/2011/main" val="1"/>
             </a:ext>
             <a:ext uri="{909E8E84-426E-40dd-AFC4-6F175D3DCCD1}">
-              <a14:hiddenFill xmlns="" xmlns:a14="http://schemas.microsoft.com/office/drawing/2010/main">
+              <a14:hiddenFill xmlns:a14="http://schemas.microsoft.com/office/drawing/2010/main" xmlns="">
                 <a:solidFill>
                   <a:srgbClr val="FFFFFF"/>
                 </a:solidFill>
               </a14:hiddenFill>
             </a:ext>
             <a:ext uri="{91240B29-F687-4f45-9708-019B960494DF}">
-              <a14:hiddenLine xmlns="" xmlns:a14="http://schemas.microsoft.com/office/drawing/2010/main" w="9525">
+              <a14:hiddenLine xmlns:a14="http://schemas.microsoft.com/office/drawing/2010/main" xmlns="" w="9525">
                 <a:solidFill>
                   <a:srgbClr val="000000"/>
                 </a:solidFill>
@@ -3134,14 +3134,14 @@
           <a:noFill/>
           <a:extLst>
             <a:ext uri="{909E8E84-426E-40dd-AFC4-6F175D3DCCD1}">
-              <a14:hiddenFill xmlns="" xmlns:a14="http://schemas.microsoft.com/office/drawing/2010/main">
+              <a14:hiddenFill xmlns:a14="http://schemas.microsoft.com/office/drawing/2010/main" xmlns="">
                 <a:solidFill>
                   <a:srgbClr val="FFFFFF"/>
                 </a:solidFill>
               </a14:hiddenFill>
             </a:ext>
             <a:ext uri="{91240B29-F687-4f45-9708-019B960494DF}">
-              <a14:hiddenLine xmlns="" xmlns:a14="http://schemas.microsoft.com/office/drawing/2010/main" w="9525">
+              <a14:hiddenLine xmlns:a14="http://schemas.microsoft.com/office/drawing/2010/main" xmlns="" w="9525">
                 <a:solidFill>
                   <a:srgbClr val="000000"/>
                 </a:solidFill>
@@ -3332,10 +3332,10 @@
           </a:ln>
           <a:extLst>
             <a:ext uri="{FAA26D3D-D897-4be2-8F04-BA451C77F1D7}">
-              <ma14:placeholderFlag xmlns:ma14="http://schemas.microsoft.com/office/mac/drawingml/2011/main" xmlns="" val="1"/>
+              <ma14:placeholderFlag xmlns="" xmlns:ma14="http://schemas.microsoft.com/office/mac/drawingml/2011/main" val="1"/>
             </a:ext>
             <a:ext uri="{909E8E84-426E-40dd-AFC4-6F175D3DCCD1}">
-              <a14:hiddenFill xmlns="" xmlns:a14="http://schemas.microsoft.com/office/drawing/2010/main">
+              <a14:hiddenFill xmlns:a14="http://schemas.microsoft.com/office/drawing/2010/main" xmlns="">
                 <a:solidFill>
                   <a:srgbClr val="FFFFFF"/>
                 </a:solidFill>
@@ -3358,17 +3358,17 @@
           <a:noFill/>
           <a:extLst>
             <a:ext uri="{FAA26D3D-D897-4be2-8F04-BA451C77F1D7}">
-              <ma14:placeholderFlag xmlns:ma14="http://schemas.microsoft.com/office/mac/drawingml/2011/main" xmlns="" val="1"/>
+              <ma14:placeholderFlag xmlns="" xmlns:ma14="http://schemas.microsoft.com/office/mac/drawingml/2011/main" val="1"/>
             </a:ext>
             <a:ext uri="{909E8E84-426E-40dd-AFC4-6F175D3DCCD1}">
-              <a14:hiddenFill xmlns="" xmlns:a14="http://schemas.microsoft.com/office/drawing/2010/main">
+              <a14:hiddenFill xmlns:a14="http://schemas.microsoft.com/office/drawing/2010/main" xmlns="">
                 <a:solidFill>
                   <a:srgbClr val="FFFFFF"/>
                 </a:solidFill>
               </a14:hiddenFill>
             </a:ext>
             <a:ext uri="{91240B29-F687-4f45-9708-019B960494DF}">
-              <a14:hiddenLine xmlns="" xmlns:a14="http://schemas.microsoft.com/office/drawing/2010/main" w="9525">
+              <a14:hiddenLine xmlns:a14="http://schemas.microsoft.com/office/drawing/2010/main" xmlns="" w="9525">
                 <a:solidFill>
                   <a:srgbClr val="000000"/>
                 </a:solidFill>
@@ -3407,14 +3407,14 @@
           <a:noFill/>
           <a:extLst>
             <a:ext uri="{909E8E84-426E-40dd-AFC4-6F175D3DCCD1}">
-              <a14:hiddenFill xmlns="" xmlns:a14="http://schemas.microsoft.com/office/drawing/2010/main">
+              <a14:hiddenFill xmlns:a14="http://schemas.microsoft.com/office/drawing/2010/main" xmlns="">
                 <a:solidFill>
                   <a:srgbClr val="FFFFFF"/>
                 </a:solidFill>
               </a14:hiddenFill>
             </a:ext>
             <a:ext uri="{91240B29-F687-4f45-9708-019B960494DF}">
-              <a14:hiddenLine xmlns="" xmlns:a14="http://schemas.microsoft.com/office/drawing/2010/main" w="9525">
+              <a14:hiddenLine xmlns:a14="http://schemas.microsoft.com/office/drawing/2010/main" xmlns="" w="9525">
                 <a:solidFill>
                   <a:srgbClr val="000000"/>
                 </a:solidFill>
@@ -3605,10 +3605,10 @@
           </a:ln>
           <a:extLst>
             <a:ext uri="{FAA26D3D-D897-4be2-8F04-BA451C77F1D7}">
-              <ma14:placeholderFlag xmlns:ma14="http://schemas.microsoft.com/office/mac/drawingml/2011/main" xmlns="" val="1"/>
+              <ma14:placeholderFlag xmlns="" xmlns:ma14="http://schemas.microsoft.com/office/mac/drawingml/2011/main" val="1"/>
             </a:ext>
             <a:ext uri="{909E8E84-426E-40dd-AFC4-6F175D3DCCD1}">
-              <a14:hiddenFill xmlns="" xmlns:a14="http://schemas.microsoft.com/office/drawing/2010/main">
+              <a14:hiddenFill xmlns:a14="http://schemas.microsoft.com/office/drawing/2010/main" xmlns="">
                 <a:solidFill>
                   <a:srgbClr val="FFFFFF"/>
                 </a:solidFill>
@@ -3631,17 +3631,17 @@
           <a:noFill/>
           <a:extLst>
             <a:ext uri="{FAA26D3D-D897-4be2-8F04-BA451C77F1D7}">
-              <ma14:placeholderFlag xmlns:ma14="http://schemas.microsoft.com/office/mac/drawingml/2011/main" xmlns="" val="1"/>
+              <ma14:placeholderFlag xmlns="" xmlns:ma14="http://schemas.microsoft.com/office/mac/drawingml/2011/main" val="1"/>
             </a:ext>
             <a:ext uri="{909E8E84-426E-40dd-AFC4-6F175D3DCCD1}">
-              <a14:hiddenFill xmlns="" xmlns:a14="http://schemas.microsoft.com/office/drawing/2010/main">
+              <a14:hiddenFill xmlns:a14="http://schemas.microsoft.com/office/drawing/2010/main" xmlns="">
                 <a:solidFill>
                   <a:srgbClr val="FFFFFF"/>
                 </a:solidFill>
               </a14:hiddenFill>
             </a:ext>
             <a:ext uri="{91240B29-F687-4f45-9708-019B960494DF}">
-              <a14:hiddenLine xmlns="" xmlns:a14="http://schemas.microsoft.com/office/drawing/2010/main" w="9525">
+              <a14:hiddenLine xmlns:a14="http://schemas.microsoft.com/office/drawing/2010/main" xmlns="" w="9525">
                 <a:solidFill>
                   <a:srgbClr val="000000"/>
                 </a:solidFill>
@@ -3680,14 +3680,14 @@
           <a:noFill/>
           <a:extLst>
             <a:ext uri="{909E8E84-426E-40dd-AFC4-6F175D3DCCD1}">
-              <a14:hiddenFill xmlns="" xmlns:a14="http://schemas.microsoft.com/office/drawing/2010/main">
+              <a14:hiddenFill xmlns:a14="http://schemas.microsoft.com/office/drawing/2010/main" xmlns="">
                 <a:solidFill>
                   <a:srgbClr val="FFFFFF"/>
                 </a:solidFill>
               </a14:hiddenFill>
             </a:ext>
             <a:ext uri="{91240B29-F687-4f45-9708-019B960494DF}">
-              <a14:hiddenLine xmlns="" xmlns:a14="http://schemas.microsoft.com/office/drawing/2010/main" w="9525">
+              <a14:hiddenLine xmlns:a14="http://schemas.microsoft.com/office/drawing/2010/main" xmlns="" w="9525">
                 <a:solidFill>
                   <a:srgbClr val="000000"/>
                 </a:solidFill>
@@ -3878,10 +3878,10 @@
           </a:ln>
           <a:extLst>
             <a:ext uri="{FAA26D3D-D897-4be2-8F04-BA451C77F1D7}">
-              <ma14:placeholderFlag xmlns:ma14="http://schemas.microsoft.com/office/mac/drawingml/2011/main" xmlns="" val="1"/>
+              <ma14:placeholderFlag xmlns="" xmlns:ma14="http://schemas.microsoft.com/office/mac/drawingml/2011/main" val="1"/>
             </a:ext>
             <a:ext uri="{909E8E84-426E-40dd-AFC4-6F175D3DCCD1}">
-              <a14:hiddenFill xmlns="" xmlns:a14="http://schemas.microsoft.com/office/drawing/2010/main">
+              <a14:hiddenFill xmlns:a14="http://schemas.microsoft.com/office/drawing/2010/main" xmlns="">
                 <a:solidFill>
                   <a:srgbClr val="FFFFFF"/>
                 </a:solidFill>
@@ -3904,17 +3904,17 @@
           <a:noFill/>
           <a:extLst>
             <a:ext uri="{FAA26D3D-D897-4be2-8F04-BA451C77F1D7}">
-              <ma14:placeholderFlag xmlns:ma14="http://schemas.microsoft.com/office/mac/drawingml/2011/main" xmlns="" val="1"/>
+              <ma14:placeholderFlag xmlns="" xmlns:ma14="http://schemas.microsoft.com/office/mac/drawingml/2011/main" val="1"/>
             </a:ext>
             <a:ext uri="{909E8E84-426E-40dd-AFC4-6F175D3DCCD1}">
-              <a14:hiddenFill xmlns="" xmlns:a14="http://schemas.microsoft.com/office/drawing/2010/main">
+              <a14:hiddenFill xmlns:a14="http://schemas.microsoft.com/office/drawing/2010/main" xmlns="">
                 <a:solidFill>
                   <a:srgbClr val="FFFFFF"/>
                 </a:solidFill>
               </a14:hiddenFill>
             </a:ext>
             <a:ext uri="{91240B29-F687-4f45-9708-019B960494DF}">
-              <a14:hiddenLine xmlns="" xmlns:a14="http://schemas.microsoft.com/office/drawing/2010/main" w="9525">
+              <a14:hiddenLine xmlns:a14="http://schemas.microsoft.com/office/drawing/2010/main" xmlns="" w="9525">
                 <a:solidFill>
                   <a:srgbClr val="000000"/>
                 </a:solidFill>
@@ -3953,14 +3953,14 @@
           <a:noFill/>
           <a:extLst>
             <a:ext uri="{909E8E84-426E-40dd-AFC4-6F175D3DCCD1}">
-              <a14:hiddenFill xmlns="" xmlns:a14="http://schemas.microsoft.com/office/drawing/2010/main">
+              <a14:hiddenFill xmlns:a14="http://schemas.microsoft.com/office/drawing/2010/main" xmlns="">
                 <a:solidFill>
                   <a:srgbClr val="FFFFFF"/>
                 </a:solidFill>
               </a14:hiddenFill>
             </a:ext>
             <a:ext uri="{91240B29-F687-4f45-9708-019B960494DF}">
-              <a14:hiddenLine xmlns="" xmlns:a14="http://schemas.microsoft.com/office/drawing/2010/main" w="9525">
+              <a14:hiddenLine xmlns:a14="http://schemas.microsoft.com/office/drawing/2010/main" xmlns="" w="9525">
                 <a:solidFill>
                   <a:srgbClr val="000000"/>
                 </a:solidFill>
@@ -4151,10 +4151,10 @@
           </a:ln>
           <a:extLst>
             <a:ext uri="{FAA26D3D-D897-4be2-8F04-BA451C77F1D7}">
-              <ma14:placeholderFlag xmlns:ma14="http://schemas.microsoft.com/office/mac/drawingml/2011/main" xmlns="" val="1"/>
+              <ma14:placeholderFlag xmlns="" xmlns:ma14="http://schemas.microsoft.com/office/mac/drawingml/2011/main" val="1"/>
             </a:ext>
             <a:ext uri="{909E8E84-426E-40dd-AFC4-6F175D3DCCD1}">
-              <a14:hiddenFill xmlns="" xmlns:a14="http://schemas.microsoft.com/office/drawing/2010/main">
+              <a14:hiddenFill xmlns:a14="http://schemas.microsoft.com/office/drawing/2010/main" xmlns="">
                 <a:solidFill>
                   <a:srgbClr val="FFFFFF"/>
                 </a:solidFill>
@@ -4177,17 +4177,17 @@
           <a:noFill/>
           <a:extLst>
             <a:ext uri="{FAA26D3D-D897-4be2-8F04-BA451C77F1D7}">
-              <ma14:placeholderFlag xmlns:ma14="http://schemas.microsoft.com/office/mac/drawingml/2011/main" xmlns="" val="1"/>
+              <ma14:placeholderFlag xmlns="" xmlns:ma14="http://schemas.microsoft.com/office/mac/drawingml/2011/main" val="1"/>
             </a:ext>
             <a:ext uri="{909E8E84-426E-40dd-AFC4-6F175D3DCCD1}">
-              <a14:hiddenFill xmlns="" xmlns:a14="http://schemas.microsoft.com/office/drawing/2010/main">
+              <a14:hiddenFill xmlns:a14="http://schemas.microsoft.com/office/drawing/2010/main" xmlns="">
                 <a:solidFill>
                   <a:srgbClr val="FFFFFF"/>
                 </a:solidFill>
               </a14:hiddenFill>
             </a:ext>
             <a:ext uri="{91240B29-F687-4f45-9708-019B960494DF}">
-              <a14:hiddenLine xmlns="" xmlns:a14="http://schemas.microsoft.com/office/drawing/2010/main" w="9525">
+              <a14:hiddenLine xmlns:a14="http://schemas.microsoft.com/office/drawing/2010/main" xmlns="" w="9525">
                 <a:solidFill>
                   <a:srgbClr val="000000"/>
                 </a:solidFill>
@@ -4226,14 +4226,14 @@
           <a:noFill/>
           <a:extLst>
             <a:ext uri="{909E8E84-426E-40dd-AFC4-6F175D3DCCD1}">
-              <a14:hiddenFill xmlns="" xmlns:a14="http://schemas.microsoft.com/office/drawing/2010/main">
+              <a14:hiddenFill xmlns:a14="http://schemas.microsoft.com/office/drawing/2010/main" xmlns="">
                 <a:solidFill>
                   <a:srgbClr val="FFFFFF"/>
                 </a:solidFill>
               </a14:hiddenFill>
             </a:ext>
             <a:ext uri="{91240B29-F687-4f45-9708-019B960494DF}">
-              <a14:hiddenLine xmlns="" xmlns:a14="http://schemas.microsoft.com/office/drawing/2010/main" w="9525">
+              <a14:hiddenLine xmlns:a14="http://schemas.microsoft.com/office/drawing/2010/main" xmlns="" w="9525">
                 <a:solidFill>
                   <a:srgbClr val="000000"/>
                 </a:solidFill>
@@ -4424,10 +4424,10 @@
           </a:ln>
           <a:extLst>
             <a:ext uri="{FAA26D3D-D897-4be2-8F04-BA451C77F1D7}">
-              <ma14:placeholderFlag xmlns:ma14="http://schemas.microsoft.com/office/mac/drawingml/2011/main" xmlns="" val="1"/>
+              <ma14:placeholderFlag xmlns="" xmlns:ma14="http://schemas.microsoft.com/office/mac/drawingml/2011/main" val="1"/>
             </a:ext>
             <a:ext uri="{909E8E84-426E-40dd-AFC4-6F175D3DCCD1}">
-              <a14:hiddenFill xmlns="" xmlns:a14="http://schemas.microsoft.com/office/drawing/2010/main">
+              <a14:hiddenFill xmlns:a14="http://schemas.microsoft.com/office/drawing/2010/main" xmlns="">
                 <a:solidFill>
                   <a:srgbClr val="FFFFFF"/>
                 </a:solidFill>
@@ -4450,17 +4450,17 @@
           <a:noFill/>
           <a:extLst>
             <a:ext uri="{FAA26D3D-D897-4be2-8F04-BA451C77F1D7}">
-              <ma14:placeholderFlag xmlns:ma14="http://schemas.microsoft.com/office/mac/drawingml/2011/main" xmlns="" val="1"/>
+              <ma14:placeholderFlag xmlns="" xmlns:ma14="http://schemas.microsoft.com/office/mac/drawingml/2011/main" val="1"/>
             </a:ext>
             <a:ext uri="{909E8E84-426E-40dd-AFC4-6F175D3DCCD1}">
-              <a14:hiddenFill xmlns="" xmlns:a14="http://schemas.microsoft.com/office/drawing/2010/main">
+              <a14:hiddenFill xmlns:a14="http://schemas.microsoft.com/office/drawing/2010/main" xmlns="">
                 <a:solidFill>
                   <a:srgbClr val="FFFFFF"/>
                 </a:solidFill>
               </a14:hiddenFill>
             </a:ext>
             <a:ext uri="{91240B29-F687-4f45-9708-019B960494DF}">
-              <a14:hiddenLine xmlns="" xmlns:a14="http://schemas.microsoft.com/office/drawing/2010/main" w="9525">
+              <a14:hiddenLine xmlns:a14="http://schemas.microsoft.com/office/drawing/2010/main" xmlns="" w="9525">
                 <a:solidFill>
                   <a:srgbClr val="000000"/>
                 </a:solidFill>
@@ -4499,14 +4499,14 @@
           <a:noFill/>
           <a:extLst>
             <a:ext uri="{909E8E84-426E-40dd-AFC4-6F175D3DCCD1}">
-              <a14:hiddenFill xmlns="" xmlns:a14="http://schemas.microsoft.com/office/drawing/2010/main">
+              <a14:hiddenFill xmlns:a14="http://schemas.microsoft.com/office/drawing/2010/main" xmlns="">
                 <a:solidFill>
                   <a:srgbClr val="FFFFFF"/>
                 </a:solidFill>
               </a14:hiddenFill>
             </a:ext>
             <a:ext uri="{91240B29-F687-4f45-9708-019B960494DF}">
-              <a14:hiddenLine xmlns="" xmlns:a14="http://schemas.microsoft.com/office/drawing/2010/main" w="9525">
+              <a14:hiddenLine xmlns:a14="http://schemas.microsoft.com/office/drawing/2010/main" xmlns="" w="9525">
                 <a:solidFill>
                   <a:srgbClr val="000000"/>
                 </a:solidFill>
@@ -4834,10 +4834,10 @@
           </a:ln>
           <a:extLst>
             <a:ext uri="{FAA26D3D-D897-4be2-8F04-BA451C77F1D7}">
-              <ma14:placeholderFlag xmlns:ma14="http://schemas.microsoft.com/office/mac/drawingml/2011/main" xmlns="" val="1"/>
+              <ma14:placeholderFlag xmlns="" xmlns:ma14="http://schemas.microsoft.com/office/mac/drawingml/2011/main" val="1"/>
             </a:ext>
             <a:ext uri="{909E8E84-426E-40dd-AFC4-6F175D3DCCD1}">
-              <a14:hiddenFill xmlns="" xmlns:a14="http://schemas.microsoft.com/office/drawing/2010/main">
+              <a14:hiddenFill xmlns:a14="http://schemas.microsoft.com/office/drawing/2010/main" xmlns="">
                 <a:solidFill>
                   <a:srgbClr val="FFFFFF"/>
                 </a:solidFill>
@@ -4860,17 +4860,17 @@
           <a:noFill/>
           <a:extLst>
             <a:ext uri="{FAA26D3D-D897-4be2-8F04-BA451C77F1D7}">
-              <ma14:placeholderFlag xmlns:ma14="http://schemas.microsoft.com/office/mac/drawingml/2011/main" xmlns="" val="1"/>
+              <ma14:placeholderFlag xmlns="" xmlns:ma14="http://schemas.microsoft.com/office/mac/drawingml/2011/main" val="1"/>
             </a:ext>
             <a:ext uri="{909E8E84-426E-40dd-AFC4-6F175D3DCCD1}">
-              <a14:hiddenFill xmlns="" xmlns:a14="http://schemas.microsoft.com/office/drawing/2010/main">
+              <a14:hiddenFill xmlns:a14="http://schemas.microsoft.com/office/drawing/2010/main" xmlns="">
                 <a:solidFill>
                   <a:srgbClr val="FFFFFF"/>
                 </a:solidFill>
               </a14:hiddenFill>
             </a:ext>
             <a:ext uri="{91240B29-F687-4f45-9708-019B960494DF}">
-              <a14:hiddenLine xmlns="" xmlns:a14="http://schemas.microsoft.com/office/drawing/2010/main" w="9525">
+              <a14:hiddenLine xmlns:a14="http://schemas.microsoft.com/office/drawing/2010/main" xmlns="" w="9525">
                 <a:solidFill>
                   <a:srgbClr val="000000"/>
                 </a:solidFill>
@@ -4909,14 +4909,14 @@
           <a:noFill/>
           <a:extLst>
             <a:ext uri="{909E8E84-426E-40dd-AFC4-6F175D3DCCD1}">
-              <a14:hiddenFill xmlns="" xmlns:a14="http://schemas.microsoft.com/office/drawing/2010/main">
+              <a14:hiddenFill xmlns:a14="http://schemas.microsoft.com/office/drawing/2010/main" xmlns="">
                 <a:solidFill>
                   <a:srgbClr val="FFFFFF"/>
                 </a:solidFill>
               </a14:hiddenFill>
             </a:ext>
             <a:ext uri="{91240B29-F687-4f45-9708-019B960494DF}">
-              <a14:hiddenLine xmlns="" xmlns:a14="http://schemas.microsoft.com/office/drawing/2010/main" w="9525">
+              <a14:hiddenLine xmlns:a14="http://schemas.microsoft.com/office/drawing/2010/main" xmlns="" w="9525">
                 <a:solidFill>
                   <a:srgbClr val="000000"/>
                 </a:solidFill>
@@ -5107,10 +5107,10 @@
           </a:ln>
           <a:extLst>
             <a:ext uri="{FAA26D3D-D897-4be2-8F04-BA451C77F1D7}">
-              <ma14:placeholderFlag xmlns:ma14="http://schemas.microsoft.com/office/mac/drawingml/2011/main" xmlns="" val="1"/>
+              <ma14:placeholderFlag xmlns="" xmlns:ma14="http://schemas.microsoft.com/office/mac/drawingml/2011/main" val="1"/>
             </a:ext>
             <a:ext uri="{909E8E84-426E-40dd-AFC4-6F175D3DCCD1}">
-              <a14:hiddenFill xmlns="" xmlns:a14="http://schemas.microsoft.com/office/drawing/2010/main">
+              <a14:hiddenFill xmlns:a14="http://schemas.microsoft.com/office/drawing/2010/main" xmlns="">
                 <a:solidFill>
                   <a:srgbClr val="FFFFFF"/>
                 </a:solidFill>
@@ -5133,17 +5133,17 @@
           <a:noFill/>
           <a:extLst>
             <a:ext uri="{FAA26D3D-D897-4be2-8F04-BA451C77F1D7}">
-              <ma14:placeholderFlag xmlns:ma14="http://schemas.microsoft.com/office/mac/drawingml/2011/main" xmlns="" val="1"/>
+              <ma14:placeholderFlag xmlns="" xmlns:ma14="http://schemas.microsoft.com/office/mac/drawingml/2011/main" val="1"/>
             </a:ext>
             <a:ext uri="{909E8E84-426E-40dd-AFC4-6F175D3DCCD1}">
-              <a14:hiddenFill xmlns="" xmlns:a14="http://schemas.microsoft.com/office/drawing/2010/main">
+              <a14:hiddenFill xmlns:a14="http://schemas.microsoft.com/office/drawing/2010/main" xmlns="">
                 <a:solidFill>
                   <a:srgbClr val="FFFFFF"/>
                 </a:solidFill>
               </a14:hiddenFill>
             </a:ext>
             <a:ext uri="{91240B29-F687-4f45-9708-019B960494DF}">
-              <a14:hiddenLine xmlns="" xmlns:a14="http://schemas.microsoft.com/office/drawing/2010/main" w="9525">
+              <a14:hiddenLine xmlns:a14="http://schemas.microsoft.com/office/drawing/2010/main" xmlns="" w="9525">
                 <a:solidFill>
                   <a:srgbClr val="000000"/>
                 </a:solidFill>
@@ -5182,14 +5182,14 @@
           <a:noFill/>
           <a:extLst>
             <a:ext uri="{909E8E84-426E-40dd-AFC4-6F175D3DCCD1}">
-              <a14:hiddenFill xmlns="" xmlns:a14="http://schemas.microsoft.com/office/drawing/2010/main">
+              <a14:hiddenFill xmlns:a14="http://schemas.microsoft.com/office/drawing/2010/main" xmlns="">
                 <a:solidFill>
                   <a:srgbClr val="FFFFFF"/>
                 </a:solidFill>
               </a14:hiddenFill>
             </a:ext>
             <a:ext uri="{91240B29-F687-4f45-9708-019B960494DF}">
-              <a14:hiddenLine xmlns="" xmlns:a14="http://schemas.microsoft.com/office/drawing/2010/main" w="9525">
+              <a14:hiddenLine xmlns:a14="http://schemas.microsoft.com/office/drawing/2010/main" xmlns="" w="9525">
                 <a:solidFill>
                   <a:srgbClr val="000000"/>
                 </a:solidFill>
@@ -5380,10 +5380,10 @@
           </a:ln>
           <a:extLst>
             <a:ext uri="{FAA26D3D-D897-4be2-8F04-BA451C77F1D7}">
-              <ma14:placeholderFlag xmlns:ma14="http://schemas.microsoft.com/office/mac/drawingml/2011/main" xmlns="" val="1"/>
+              <ma14:placeholderFlag xmlns="" xmlns:ma14="http://schemas.microsoft.com/office/mac/drawingml/2011/main" val="1"/>
             </a:ext>
             <a:ext uri="{909E8E84-426E-40dd-AFC4-6F175D3DCCD1}">
-              <a14:hiddenFill xmlns="" xmlns:a14="http://schemas.microsoft.com/office/drawing/2010/main">
+              <a14:hiddenFill xmlns:a14="http://schemas.microsoft.com/office/drawing/2010/main" xmlns="">
                 <a:solidFill>
                   <a:srgbClr val="FFFFFF"/>
                 </a:solidFill>
@@ -5406,17 +5406,17 @@
           <a:noFill/>
           <a:extLst>
             <a:ext uri="{FAA26D3D-D897-4be2-8F04-BA451C77F1D7}">
-              <ma14:placeholderFlag xmlns:ma14="http://schemas.microsoft.com/office/mac/drawingml/2011/main" xmlns="" val="1"/>
+              <ma14:placeholderFlag xmlns="" xmlns:ma14="http://schemas.microsoft.com/office/mac/drawingml/2011/main" val="1"/>
             </a:ext>
             <a:ext uri="{909E8E84-426E-40dd-AFC4-6F175D3DCCD1}">
-              <a14:hiddenFill xmlns="" xmlns:a14="http://schemas.microsoft.com/office/drawing/2010/main">
+              <a14:hiddenFill xmlns:a14="http://schemas.microsoft.com/office/drawing/2010/main" xmlns="">
                 <a:solidFill>
                   <a:srgbClr val="FFFFFF"/>
                 </a:solidFill>
               </a14:hiddenFill>
             </a:ext>
             <a:ext uri="{91240B29-F687-4f45-9708-019B960494DF}">
-              <a14:hiddenLine xmlns="" xmlns:a14="http://schemas.microsoft.com/office/drawing/2010/main" w="9525">
+              <a14:hiddenLine xmlns:a14="http://schemas.microsoft.com/office/drawing/2010/main" xmlns="" w="9525">
                 <a:solidFill>
                   <a:srgbClr val="000000"/>
                 </a:solidFill>
@@ -5455,14 +5455,14 @@
           <a:noFill/>
           <a:extLst>
             <a:ext uri="{909E8E84-426E-40dd-AFC4-6F175D3DCCD1}">
-              <a14:hiddenFill xmlns="" xmlns:a14="http://schemas.microsoft.com/office/drawing/2010/main">
+              <a14:hiddenFill xmlns:a14="http://schemas.microsoft.com/office/drawing/2010/main" xmlns="">
                 <a:solidFill>
                   <a:srgbClr val="FFFFFF"/>
                 </a:solidFill>
               </a14:hiddenFill>
             </a:ext>
             <a:ext uri="{91240B29-F687-4f45-9708-019B960494DF}">
-              <a14:hiddenLine xmlns="" xmlns:a14="http://schemas.microsoft.com/office/drawing/2010/main" w="9525">
+              <a14:hiddenLine xmlns:a14="http://schemas.microsoft.com/office/drawing/2010/main" xmlns="" w="9525">
                 <a:solidFill>
                   <a:srgbClr val="000000"/>
                 </a:solidFill>
@@ -5653,10 +5653,10 @@
           </a:ln>
           <a:extLst>
             <a:ext uri="{FAA26D3D-D897-4be2-8F04-BA451C77F1D7}">
-              <ma14:placeholderFlag xmlns:ma14="http://schemas.microsoft.com/office/mac/drawingml/2011/main" xmlns="" val="1"/>
+              <ma14:placeholderFlag xmlns="" xmlns:ma14="http://schemas.microsoft.com/office/mac/drawingml/2011/main" val="1"/>
             </a:ext>
             <a:ext uri="{909E8E84-426E-40dd-AFC4-6F175D3DCCD1}">
-              <a14:hiddenFill xmlns="" xmlns:a14="http://schemas.microsoft.com/office/drawing/2010/main">
+              <a14:hiddenFill xmlns:a14="http://schemas.microsoft.com/office/drawing/2010/main" xmlns="">
                 <a:solidFill>
                   <a:srgbClr val="FFFFFF"/>
                 </a:solidFill>
@@ -5679,17 +5679,17 @@
           <a:noFill/>
           <a:extLst>
             <a:ext uri="{FAA26D3D-D897-4be2-8F04-BA451C77F1D7}">
-              <ma14:placeholderFlag xmlns:ma14="http://schemas.microsoft.com/office/mac/drawingml/2011/main" xmlns="" val="1"/>
+              <ma14:placeholderFlag xmlns="" xmlns:ma14="http://schemas.microsoft.com/office/mac/drawingml/2011/main" val="1"/>
             </a:ext>
             <a:ext uri="{909E8E84-426E-40dd-AFC4-6F175D3DCCD1}">
-              <a14:hiddenFill xmlns="" xmlns:a14="http://schemas.microsoft.com/office/drawing/2010/main">
+              <a14:hiddenFill xmlns:a14="http://schemas.microsoft.com/office/drawing/2010/main" xmlns="">
                 <a:solidFill>
                   <a:srgbClr val="FFFFFF"/>
                 </a:solidFill>
               </a14:hiddenFill>
             </a:ext>
             <a:ext uri="{91240B29-F687-4f45-9708-019B960494DF}">
-              <a14:hiddenLine xmlns="" xmlns:a14="http://schemas.microsoft.com/office/drawing/2010/main" w="9525">
+              <a14:hiddenLine xmlns:a14="http://schemas.microsoft.com/office/drawing/2010/main" xmlns="" w="9525">
                 <a:solidFill>
                   <a:srgbClr val="000000"/>
                 </a:solidFill>
@@ -5728,14 +5728,14 @@
           <a:noFill/>
           <a:extLst>
             <a:ext uri="{909E8E84-426E-40dd-AFC4-6F175D3DCCD1}">
-              <a14:hiddenFill xmlns="" xmlns:a14="http://schemas.microsoft.com/office/drawing/2010/main">
+              <a14:hiddenFill xmlns:a14="http://schemas.microsoft.com/office/drawing/2010/main" xmlns="">
                 <a:solidFill>
                   <a:srgbClr val="FFFFFF"/>
                 </a:solidFill>
               </a14:hiddenFill>
             </a:ext>
             <a:ext uri="{91240B29-F687-4f45-9708-019B960494DF}">
-              <a14:hiddenLine xmlns="" xmlns:a14="http://schemas.microsoft.com/office/drawing/2010/main" w="9525">
+              <a14:hiddenLine xmlns:a14="http://schemas.microsoft.com/office/drawing/2010/main" xmlns="" w="9525">
                 <a:solidFill>
                   <a:srgbClr val="000000"/>
                 </a:solidFill>
@@ -5926,10 +5926,10 @@
           </a:ln>
           <a:extLst>
             <a:ext uri="{FAA26D3D-D897-4be2-8F04-BA451C77F1D7}">
-              <ma14:placeholderFlag xmlns:ma14="http://schemas.microsoft.com/office/mac/drawingml/2011/main" xmlns="" val="1"/>
+              <ma14:placeholderFlag xmlns="" xmlns:ma14="http://schemas.microsoft.com/office/mac/drawingml/2011/main" val="1"/>
             </a:ext>
             <a:ext uri="{909E8E84-426E-40dd-AFC4-6F175D3DCCD1}">
-              <a14:hiddenFill xmlns="" xmlns:a14="http://schemas.microsoft.com/office/drawing/2010/main">
+              <a14:hiddenFill xmlns:a14="http://schemas.microsoft.com/office/drawing/2010/main" xmlns="">
                 <a:solidFill>
                   <a:srgbClr val="FFFFFF"/>
                 </a:solidFill>
@@ -5952,17 +5952,17 @@
           <a:noFill/>
           <a:extLst>
             <a:ext uri="{FAA26D3D-D897-4be2-8F04-BA451C77F1D7}">
-              <ma14:placeholderFlag xmlns:ma14="http://schemas.microsoft.com/office/mac/drawingml/2011/main" xmlns="" val="1"/>
+              <ma14:placeholderFlag xmlns="" xmlns:ma14="http://schemas.microsoft.com/office/mac/drawingml/2011/main" val="1"/>
             </a:ext>
             <a:ext uri="{909E8E84-426E-40dd-AFC4-6F175D3DCCD1}">
-              <a14:hiddenFill xmlns="" xmlns:a14="http://schemas.microsoft.com/office/drawing/2010/main">
+              <a14:hiddenFill xmlns:a14="http://schemas.microsoft.com/office/drawing/2010/main" xmlns="">
                 <a:solidFill>
                   <a:srgbClr val="FFFFFF"/>
                 </a:solidFill>
               </a14:hiddenFill>
             </a:ext>
             <a:ext uri="{91240B29-F687-4f45-9708-019B960494DF}">
-              <a14:hiddenLine xmlns="" xmlns:a14="http://schemas.microsoft.com/office/drawing/2010/main" w="9525">
+              <a14:hiddenLine xmlns:a14="http://schemas.microsoft.com/office/drawing/2010/main" xmlns="" w="9525">
                 <a:solidFill>
                   <a:srgbClr val="000000"/>
                 </a:solidFill>
@@ -6001,14 +6001,14 @@
           <a:noFill/>
           <a:extLst>
             <a:ext uri="{909E8E84-426E-40dd-AFC4-6F175D3DCCD1}">
-              <a14:hiddenFill xmlns="" xmlns:a14="http://schemas.microsoft.com/office/drawing/2010/main">
+              <a14:hiddenFill xmlns:a14="http://schemas.microsoft.com/office/drawing/2010/main" xmlns="">
                 <a:solidFill>
                   <a:srgbClr val="FFFFFF"/>
                 </a:solidFill>
               </a14:hiddenFill>
             </a:ext>
             <a:ext uri="{91240B29-F687-4f45-9708-019B960494DF}">
-              <a14:hiddenLine xmlns="" xmlns:a14="http://schemas.microsoft.com/office/drawing/2010/main" w="9525">
+              <a14:hiddenLine xmlns:a14="http://schemas.microsoft.com/office/drawing/2010/main" xmlns="" w="9525">
                 <a:solidFill>
                   <a:srgbClr val="000000"/>
                 </a:solidFill>
@@ -6199,10 +6199,10 @@
           </a:ln>
           <a:extLst>
             <a:ext uri="{FAA26D3D-D897-4be2-8F04-BA451C77F1D7}">
-              <ma14:placeholderFlag xmlns:ma14="http://schemas.microsoft.com/office/mac/drawingml/2011/main" xmlns="" val="1"/>
+              <ma14:placeholderFlag xmlns="" xmlns:ma14="http://schemas.microsoft.com/office/mac/drawingml/2011/main" val="1"/>
             </a:ext>
             <a:ext uri="{909E8E84-426E-40dd-AFC4-6F175D3DCCD1}">
-              <a14:hiddenFill xmlns="" xmlns:a14="http://schemas.microsoft.com/office/drawing/2010/main">
+              <a14:hiddenFill xmlns:a14="http://schemas.microsoft.com/office/drawing/2010/main" xmlns="">
                 <a:solidFill>
                   <a:srgbClr val="FFFFFF"/>
                 </a:solidFill>
@@ -6225,17 +6225,17 @@
           <a:noFill/>
           <a:extLst>
             <a:ext uri="{FAA26D3D-D897-4be2-8F04-BA451C77F1D7}">
-              <ma14:placeholderFlag xmlns:ma14="http://schemas.microsoft.com/office/mac/drawingml/2011/main" xmlns="" val="1"/>
+              <ma14:placeholderFlag xmlns="" xmlns:ma14="http://schemas.microsoft.com/office/mac/drawingml/2011/main" val="1"/>
             </a:ext>
             <a:ext uri="{909E8E84-426E-40dd-AFC4-6F175D3DCCD1}">
-              <a14:hiddenFill xmlns="" xmlns:a14="http://schemas.microsoft.com/office/drawing/2010/main">
+              <a14:hiddenFill xmlns:a14="http://schemas.microsoft.com/office/drawing/2010/main" xmlns="">
                 <a:solidFill>
                   <a:srgbClr val="FFFFFF"/>
                 </a:solidFill>
               </a14:hiddenFill>
             </a:ext>
             <a:ext uri="{91240B29-F687-4f45-9708-019B960494DF}">
-              <a14:hiddenLine xmlns="" xmlns:a14="http://schemas.microsoft.com/office/drawing/2010/main" w="9525">
+              <a14:hiddenLine xmlns:a14="http://schemas.microsoft.com/office/drawing/2010/main" xmlns="" w="9525">
                 <a:solidFill>
                   <a:srgbClr val="000000"/>
                 </a:solidFill>
@@ -6274,14 +6274,14 @@
           <a:noFill/>
           <a:extLst>
             <a:ext uri="{909E8E84-426E-40dd-AFC4-6F175D3DCCD1}">
-              <a14:hiddenFill xmlns="" xmlns:a14="http://schemas.microsoft.com/office/drawing/2010/main">
+              <a14:hiddenFill xmlns:a14="http://schemas.microsoft.com/office/drawing/2010/main" xmlns="">
                 <a:solidFill>
                   <a:srgbClr val="FFFFFF"/>
                 </a:solidFill>
               </a14:hiddenFill>
             </a:ext>
             <a:ext uri="{91240B29-F687-4f45-9708-019B960494DF}">
-              <a14:hiddenLine xmlns="" xmlns:a14="http://schemas.microsoft.com/office/drawing/2010/main" w="9525">
+              <a14:hiddenLine xmlns:a14="http://schemas.microsoft.com/office/drawing/2010/main" xmlns="" w="9525">
                 <a:solidFill>
                   <a:srgbClr val="000000"/>
                 </a:solidFill>
@@ -21978,8 +21978,8 @@
         </p:nvSpPr>
         <p:spPr>
           <a:xfrm>
-            <a:off x="533400" y="2362200"/>
-            <a:ext cx="8382000" cy="3391698"/>
+            <a:off x="457200" y="2057400"/>
+            <a:ext cx="8382000" cy="4031873"/>
           </a:xfrm>
           <a:prstGeom prst="rect">
             <a:avLst/>
@@ -21992,39 +21992,17 @@
           <a:lstStyle/>
           <a:p>
             <a:pPr>
-              <a:lnSpc>
-                <a:spcPct val="90000"/>
-              </a:lnSpc>
               <a:spcAft>
-                <a:spcPts val="1200"/>
+                <a:spcPts val="2400"/>
               </a:spcAft>
             </a:pPr>
             <a:r>
-              <a:rPr lang="en-US" sz="3600" dirty="0">
-                <a:solidFill>
-                  <a:srgbClr val="C00000"/>
-                </a:solidFill>
-              </a:rPr>
-              <a:t>A Binary Search Tree </a:t>
-            </a:r>
-            <a:r>
               <a:rPr lang="en-US" sz="3600" dirty="0"/>
-              <a:t>is binary tree with </a:t>
-            </a:r>
-            <a:r>
-              <a:rPr lang="en-US" sz="3600" b="1" dirty="0"/>
-              <a:t>no duplicate </a:t>
-            </a:r>
-            <a:r>
-              <a:rPr lang="en-US" sz="3600" dirty="0"/>
-              <a:t>values in which:</a:t>
+              <a:t>a binary tree in which:</a:t>
             </a:r>
           </a:p>
           <a:p>
-            <a:pPr marL="457200" indent="-457200">
-              <a:lnSpc>
-                <a:spcPct val="90000"/>
-              </a:lnSpc>
+            <a:pPr marL="461963" indent="-461963">
               <a:spcAft>
                 <a:spcPts val="1200"/>
               </a:spcAft>
@@ -22033,38 +22011,19 @@
             </a:pPr>
             <a:r>
               <a:rPr lang="en-US" sz="3600" dirty="0"/>
-              <a:t>the data in every</a:t>
+              <a:t>there are </a:t>
             </a:r>
             <a:r>
-              <a:rPr lang="en-US" sz="3600" dirty="0">
-                <a:solidFill>
-                  <a:srgbClr val="C00000"/>
-                </a:solidFill>
-              </a:rPr>
-              <a:t> left </a:t>
+              <a:rPr lang="en-US" sz="3600" b="1" dirty="0"/>
+              <a:t>no duplicate </a:t>
             </a:r>
             <a:r>
               <a:rPr lang="en-US" sz="3600" dirty="0"/>
-              <a:t>node is </a:t>
-            </a:r>
-            <a:r>
-              <a:rPr lang="en-US" sz="3600" dirty="0">
-                <a:solidFill>
-                  <a:srgbClr val="C00000"/>
-                </a:solidFill>
-              </a:rPr>
-              <a:t>less</a:t>
-            </a:r>
-            <a:r>
-              <a:rPr lang="en-US" sz="3600" dirty="0"/>
-              <a:t> than the data in its parent</a:t>
+              <a:t>values</a:t>
             </a:r>
           </a:p>
           <a:p>
             <a:pPr marL="457200" indent="-457200">
-              <a:lnSpc>
-                <a:spcPct val="90000"/>
-              </a:lnSpc>
               <a:spcAft>
                 <a:spcPts val="1200"/>
               </a:spcAft>
@@ -22073,7 +22032,7 @@
             </a:pPr>
             <a:r>
               <a:rPr lang="en-US" sz="3600" dirty="0"/>
-              <a:t>the data in the</a:t>
+              <a:t>every</a:t>
             </a:r>
             <a:r>
               <a:rPr lang="en-US" sz="3600" dirty="0">
@@ -22081,11 +22040,55 @@
                   <a:srgbClr val="C00000"/>
                 </a:solidFill>
               </a:rPr>
-              <a:t> right </a:t>
+              <a:t> left</a:t>
             </a:r>
             <a:r>
               <a:rPr lang="en-US" sz="3600" dirty="0"/>
-              <a:t>node is </a:t>
+              <a:t> child’s data is </a:t>
+            </a:r>
+            <a:r>
+              <a:rPr lang="en-US" sz="3600" dirty="0">
+                <a:solidFill>
+                  <a:srgbClr val="C00000"/>
+                </a:solidFill>
+              </a:rPr>
+              <a:t>less</a:t>
+            </a:r>
+            <a:r>
+              <a:rPr lang="en-US" sz="3600" dirty="0"/>
+              <a:t> than </a:t>
+            </a:r>
+            <a:br>
+              <a:rPr lang="en-US" sz="3600" dirty="0"/>
+            </a:br>
+            <a:r>
+              <a:rPr lang="en-US" sz="3600" dirty="0"/>
+              <a:t>the data in its parent</a:t>
+            </a:r>
+          </a:p>
+          <a:p>
+            <a:pPr marL="457200" indent="-457200">
+              <a:spcAft>
+                <a:spcPts val="1200"/>
+              </a:spcAft>
+              <a:buFont typeface="Arial" panose="020B0604020202020204" pitchFamily="34" charset="0"/>
+              <a:buChar char="•"/>
+            </a:pPr>
+            <a:r>
+              <a:rPr lang="en-US" sz="3600" dirty="0"/>
+              <a:t>every</a:t>
+            </a:r>
+            <a:r>
+              <a:rPr lang="en-US" sz="3600" dirty="0">
+                <a:solidFill>
+                  <a:srgbClr val="C00000"/>
+                </a:solidFill>
+              </a:rPr>
+              <a:t> right</a:t>
+            </a:r>
+            <a:r>
+              <a:rPr lang="en-US" sz="3600" dirty="0"/>
+              <a:t> child’s data is </a:t>
             </a:r>
             <a:r>
               <a:rPr lang="en-US" sz="3600" dirty="0">
@@ -22097,7 +22100,7 @@
             </a:r>
             <a:r>
               <a:rPr lang="en-US" sz="3600" dirty="0"/>
-              <a:t> than the data in its parent.  </a:t>
+              <a:t> than the data in its parent</a:t>
             </a:r>
           </a:p>
         </p:txBody>
@@ -24249,14 +24252,14 @@
           <a:noFill/>
           <a:extLst>
             <a:ext uri="{909E8E84-426E-40dd-AFC4-6F175D3DCCD1}">
-              <a14:hiddenFill xmlns:a14="http://schemas.microsoft.com/office/drawing/2010/main" xmlns="">
+              <a14:hiddenFill xmlns="" xmlns:a14="http://schemas.microsoft.com/office/drawing/2010/main">
                 <a:solidFill>
                   <a:srgbClr val="FFFFFF"/>
                 </a:solidFill>
               </a14:hiddenFill>
             </a:ext>
             <a:ext uri="{91240B29-F687-4f45-9708-019B960494DF}">
-              <a14:hiddenLine xmlns:a14="http://schemas.microsoft.com/office/drawing/2010/main" xmlns="" w="9525">
+              <a14:hiddenLine xmlns="" xmlns:a14="http://schemas.microsoft.com/office/drawing/2010/main" w="9525">
                 <a:solidFill>
                   <a:srgbClr val="000000"/>
                 </a:solidFill>
@@ -24679,14 +24682,14 @@
               </a:ln>
               <a:extLst>
                 <a:ext uri="{909E8E84-426E-40dd-AFC4-6F175D3DCCD1}">
-                  <a14:hiddenFill xmlns:a14="http://schemas.microsoft.com/office/drawing/2010/main" xmlns="">
+                  <a14:hiddenFill xmlns="" xmlns:a14="http://schemas.microsoft.com/office/drawing/2010/main">
                     <a:solidFill>
                       <a:srgbClr val="FFFFFF"/>
                     </a:solidFill>
                   </a14:hiddenFill>
                 </a:ext>
                 <a:ext uri="{91240B29-F687-4f45-9708-019B960494DF}">
-                  <a14:hiddenLine xmlns:a14="http://schemas.microsoft.com/office/drawing/2010/main" xmlns="" w="9525">
+                  <a14:hiddenLine xmlns="" xmlns:a14="http://schemas.microsoft.com/office/drawing/2010/main" w="9525">
                     <a:solidFill>
                       <a:srgbClr val="000000"/>
                     </a:solidFill>
@@ -24914,14 +24917,14 @@
               </a:ln>
               <a:extLst>
                 <a:ext uri="{909E8E84-426E-40dd-AFC4-6F175D3DCCD1}">
-                  <a14:hiddenFill xmlns:a14="http://schemas.microsoft.com/office/drawing/2010/main" xmlns="">
+                  <a14:hiddenFill xmlns="" xmlns:a14="http://schemas.microsoft.com/office/drawing/2010/main">
                     <a:solidFill>
                       <a:srgbClr val="FFFFFF"/>
                     </a:solidFill>
                   </a14:hiddenFill>
                 </a:ext>
                 <a:ext uri="{91240B29-F687-4f45-9708-019B960494DF}">
-                  <a14:hiddenLine xmlns:a14="http://schemas.microsoft.com/office/drawing/2010/main" xmlns="" w="9525">
+                  <a14:hiddenLine xmlns="" xmlns:a14="http://schemas.microsoft.com/office/drawing/2010/main" w="9525">
                     <a:solidFill>
                       <a:srgbClr val="000000"/>
                     </a:solidFill>
@@ -25108,7 +25111,7 @@
               </a:ln>
               <a:extLst>
                 <a:ext uri="{909E8E84-426E-40dd-AFC4-6F175D3DCCD1}">
-                  <a14:hiddenFill xmlns:a14="http://schemas.microsoft.com/office/drawing/2010/main" xmlns="">
+                  <a14:hiddenFill xmlns="" xmlns:a14="http://schemas.microsoft.com/office/drawing/2010/main">
                     <a:solidFill>
                       <a:srgbClr val="FFFFFF"/>
                     </a:solidFill>
@@ -25267,7 +25270,7 @@
               </a:ln>
               <a:extLst>
                 <a:ext uri="{909E8E84-426E-40dd-AFC4-6F175D3DCCD1}">
-                  <a14:hiddenFill xmlns:a14="http://schemas.microsoft.com/office/drawing/2010/main" xmlns="">
+                  <a14:hiddenFill xmlns="" xmlns:a14="http://schemas.microsoft.com/office/drawing/2010/main">
                     <a:solidFill>
                       <a:srgbClr val="FFFFFF"/>
                     </a:solidFill>
@@ -25426,7 +25429,7 @@
               </a:ln>
               <a:extLst>
                 <a:ext uri="{909E8E84-426E-40dd-AFC4-6F175D3DCCD1}">
-                  <a14:hiddenFill xmlns:a14="http://schemas.microsoft.com/office/drawing/2010/main" xmlns="">
+                  <a14:hiddenFill xmlns="" xmlns:a14="http://schemas.microsoft.com/office/drawing/2010/main">
                     <a:solidFill>
                       <a:srgbClr val="FFFFFF"/>
                     </a:solidFill>
@@ -25580,14 +25583,14 @@
               </a:ln>
               <a:extLst>
                 <a:ext uri="{909E8E84-426E-40dd-AFC4-6F175D3DCCD1}">
-                  <a14:hiddenFill xmlns:a14="http://schemas.microsoft.com/office/drawing/2010/main" xmlns="">
+                  <a14:hiddenFill xmlns="" xmlns:a14="http://schemas.microsoft.com/office/drawing/2010/main">
                     <a:solidFill>
                       <a:srgbClr val="FFFFFF"/>
                     </a:solidFill>
                   </a14:hiddenFill>
                 </a:ext>
                 <a:ext uri="{91240B29-F687-4f45-9708-019B960494DF}">
-                  <a14:hiddenLine xmlns:a14="http://schemas.microsoft.com/office/drawing/2010/main" xmlns="" w="12700">
+                  <a14:hiddenLine xmlns="" xmlns:a14="http://schemas.microsoft.com/office/drawing/2010/main" w="12700">
                     <a:solidFill>
                       <a:srgbClr val="000000"/>
                     </a:solidFill>
@@ -25755,14 +25758,14 @@
               </a:ln>
               <a:extLst>
                 <a:ext uri="{909E8E84-426E-40dd-AFC4-6F175D3DCCD1}">
-                  <a14:hiddenFill xmlns:a14="http://schemas.microsoft.com/office/drawing/2010/main" xmlns="">
+                  <a14:hiddenFill xmlns="" xmlns:a14="http://schemas.microsoft.com/office/drawing/2010/main">
                     <a:solidFill>
                       <a:srgbClr val="FFFFFF"/>
                     </a:solidFill>
                   </a14:hiddenFill>
                 </a:ext>
                 <a:ext uri="{91240B29-F687-4f45-9708-019B960494DF}">
-                  <a14:hiddenLine xmlns:a14="http://schemas.microsoft.com/office/drawing/2010/main" xmlns="" w="12700">
+                  <a14:hiddenLine xmlns="" xmlns:a14="http://schemas.microsoft.com/office/drawing/2010/main" w="12700">
                     <a:solidFill>
                       <a:srgbClr val="000000"/>
                     </a:solidFill>
@@ -25930,14 +25933,14 @@
               </a:ln>
               <a:extLst>
                 <a:ext uri="{909E8E84-426E-40dd-AFC4-6F175D3DCCD1}">
-                  <a14:hiddenFill xmlns:a14="http://schemas.microsoft.com/office/drawing/2010/main" xmlns="">
+                  <a14:hiddenFill xmlns="" xmlns:a14="http://schemas.microsoft.com/office/drawing/2010/main">
                     <a:solidFill>
                       <a:srgbClr val="FFFFFF"/>
                     </a:solidFill>
                   </a14:hiddenFill>
                 </a:ext>
                 <a:ext uri="{91240B29-F687-4f45-9708-019B960494DF}">
-                  <a14:hiddenLine xmlns:a14="http://schemas.microsoft.com/office/drawing/2010/main" xmlns="" w="12700">
+                  <a14:hiddenLine xmlns="" xmlns:a14="http://schemas.microsoft.com/office/drawing/2010/main" w="12700">
                     <a:solidFill>
                       <a:srgbClr val="000000"/>
                     </a:solidFill>
@@ -26110,7 +26113,7 @@
               </a:ln>
               <a:extLst>
                 <a:ext uri="{909E8E84-426E-40dd-AFC4-6F175D3DCCD1}">
-                  <a14:hiddenFill xmlns:a14="http://schemas.microsoft.com/office/drawing/2010/main" xmlns="">
+                  <a14:hiddenFill xmlns="" xmlns:a14="http://schemas.microsoft.com/office/drawing/2010/main">
                     <a:noFill/>
                   </a14:hiddenFill>
                 </a:ext>
@@ -26151,7 +26154,7 @@
               </a:ln>
               <a:extLst>
                 <a:ext uri="{909E8E84-426E-40dd-AFC4-6F175D3DCCD1}">
-                  <a14:hiddenFill xmlns:a14="http://schemas.microsoft.com/office/drawing/2010/main" xmlns="">
+                  <a14:hiddenFill xmlns="" xmlns:a14="http://schemas.microsoft.com/office/drawing/2010/main">
                     <a:noFill/>
                   </a14:hiddenFill>
                 </a:ext>
@@ -26192,7 +26195,7 @@
               </a:ln>
               <a:extLst>
                 <a:ext uri="{909E8E84-426E-40dd-AFC4-6F175D3DCCD1}">
-                  <a14:hiddenFill xmlns:a14="http://schemas.microsoft.com/office/drawing/2010/main" xmlns="">
+                  <a14:hiddenFill xmlns="" xmlns:a14="http://schemas.microsoft.com/office/drawing/2010/main">
                     <a:solidFill>
                       <a:srgbClr val="FFFFFF"/>
                     </a:solidFill>
@@ -26351,7 +26354,7 @@
               </a:ln>
               <a:extLst>
                 <a:ext uri="{909E8E84-426E-40dd-AFC4-6F175D3DCCD1}">
-                  <a14:hiddenFill xmlns:a14="http://schemas.microsoft.com/office/drawing/2010/main" xmlns="">
+                  <a14:hiddenFill xmlns="" xmlns:a14="http://schemas.microsoft.com/office/drawing/2010/main">
                     <a:solidFill>
                       <a:srgbClr val="FFFFFF"/>
                     </a:solidFill>
@@ -26510,7 +26513,7 @@
               </a:ln>
               <a:extLst>
                 <a:ext uri="{909E8E84-426E-40dd-AFC4-6F175D3DCCD1}">
-                  <a14:hiddenFill xmlns:a14="http://schemas.microsoft.com/office/drawing/2010/main" xmlns="">
+                  <a14:hiddenFill xmlns="" xmlns:a14="http://schemas.microsoft.com/office/drawing/2010/main">
                     <a:solidFill>
                       <a:srgbClr val="FFFFFF"/>
                     </a:solidFill>
@@ -26664,14 +26667,14 @@
               </a:ln>
               <a:extLst>
                 <a:ext uri="{909E8E84-426E-40dd-AFC4-6F175D3DCCD1}">
-                  <a14:hiddenFill xmlns:a14="http://schemas.microsoft.com/office/drawing/2010/main" xmlns="">
+                  <a14:hiddenFill xmlns="" xmlns:a14="http://schemas.microsoft.com/office/drawing/2010/main">
                     <a:solidFill>
                       <a:srgbClr val="FFFFFF"/>
                     </a:solidFill>
                   </a14:hiddenFill>
                 </a:ext>
                 <a:ext uri="{91240B29-F687-4f45-9708-019B960494DF}">
-                  <a14:hiddenLine xmlns:a14="http://schemas.microsoft.com/office/drawing/2010/main" xmlns="" w="12700">
+                  <a14:hiddenLine xmlns="" xmlns:a14="http://schemas.microsoft.com/office/drawing/2010/main" w="12700">
                     <a:solidFill>
                       <a:srgbClr val="000000"/>
                     </a:solidFill>
@@ -26839,14 +26842,14 @@
               </a:ln>
               <a:extLst>
                 <a:ext uri="{909E8E84-426E-40dd-AFC4-6F175D3DCCD1}">
-                  <a14:hiddenFill xmlns:a14="http://schemas.microsoft.com/office/drawing/2010/main" xmlns="">
+                  <a14:hiddenFill xmlns="" xmlns:a14="http://schemas.microsoft.com/office/drawing/2010/main">
                     <a:solidFill>
                       <a:srgbClr val="FFFFFF"/>
                     </a:solidFill>
                   </a14:hiddenFill>
                 </a:ext>
                 <a:ext uri="{91240B29-F687-4f45-9708-019B960494DF}">
-                  <a14:hiddenLine xmlns:a14="http://schemas.microsoft.com/office/drawing/2010/main" xmlns="" w="12700">
+                  <a14:hiddenLine xmlns="" xmlns:a14="http://schemas.microsoft.com/office/drawing/2010/main" w="12700">
                     <a:solidFill>
                       <a:srgbClr val="000000"/>
                     </a:solidFill>
@@ -27019,7 +27022,7 @@
               </a:ln>
               <a:extLst>
                 <a:ext uri="{909E8E84-426E-40dd-AFC4-6F175D3DCCD1}">
-                  <a14:hiddenFill xmlns:a14="http://schemas.microsoft.com/office/drawing/2010/main" xmlns="">
+                  <a14:hiddenFill xmlns="" xmlns:a14="http://schemas.microsoft.com/office/drawing/2010/main">
                     <a:noFill/>
                   </a14:hiddenFill>
                 </a:ext>
@@ -27060,7 +27063,7 @@
               </a:ln>
               <a:extLst>
                 <a:ext uri="{909E8E84-426E-40dd-AFC4-6F175D3DCCD1}">
-                  <a14:hiddenFill xmlns:a14="http://schemas.microsoft.com/office/drawing/2010/main" xmlns="">
+                  <a14:hiddenFill xmlns="" xmlns:a14="http://schemas.microsoft.com/office/drawing/2010/main">
                     <a:noFill/>
                   </a14:hiddenFill>
                 </a:ext>
@@ -27101,7 +27104,7 @@
               </a:ln>
               <a:extLst>
                 <a:ext uri="{909E8E84-426E-40dd-AFC4-6F175D3DCCD1}">
-                  <a14:hiddenFill xmlns:a14="http://schemas.microsoft.com/office/drawing/2010/main" xmlns="">
+                  <a14:hiddenFill xmlns="" xmlns:a14="http://schemas.microsoft.com/office/drawing/2010/main">
                     <a:solidFill>
                       <a:srgbClr val="FFFFFF"/>
                     </a:solidFill>
@@ -27260,7 +27263,7 @@
               </a:ln>
               <a:extLst>
                 <a:ext uri="{909E8E84-426E-40dd-AFC4-6F175D3DCCD1}">
-                  <a14:hiddenFill xmlns:a14="http://schemas.microsoft.com/office/drawing/2010/main" xmlns="">
+                  <a14:hiddenFill xmlns="" xmlns:a14="http://schemas.microsoft.com/office/drawing/2010/main">
                     <a:noFill/>
                   </a14:hiddenFill>
                 </a:ext>
@@ -27301,7 +27304,7 @@
               </a:ln>
               <a:extLst>
                 <a:ext uri="{909E8E84-426E-40dd-AFC4-6F175D3DCCD1}">
-                  <a14:hiddenFill xmlns:a14="http://schemas.microsoft.com/office/drawing/2010/main" xmlns="">
+                  <a14:hiddenFill xmlns="" xmlns:a14="http://schemas.microsoft.com/office/drawing/2010/main">
                     <a:noFill/>
                   </a14:hiddenFill>
                 </a:ext>
@@ -27337,14 +27340,14 @@
               </a:ln>
               <a:extLst>
                 <a:ext uri="{909E8E84-426E-40dd-AFC4-6F175D3DCCD1}">
-                  <a14:hiddenFill xmlns:a14="http://schemas.microsoft.com/office/drawing/2010/main" xmlns="">
+                  <a14:hiddenFill xmlns="" xmlns:a14="http://schemas.microsoft.com/office/drawing/2010/main">
                     <a:solidFill>
                       <a:srgbClr val="FFFFFF"/>
                     </a:solidFill>
                   </a14:hiddenFill>
                 </a:ext>
                 <a:ext uri="{91240B29-F687-4f45-9708-019B960494DF}">
-                  <a14:hiddenLine xmlns:a14="http://schemas.microsoft.com/office/drawing/2010/main" xmlns="" w="12700">
+                  <a14:hiddenLine xmlns="" xmlns:a14="http://schemas.microsoft.com/office/drawing/2010/main" w="12700">
                     <a:solidFill>
                       <a:srgbClr val="000000"/>
                     </a:solidFill>
@@ -27512,14 +27515,14 @@
               </a:ln>
               <a:extLst>
                 <a:ext uri="{909E8E84-426E-40dd-AFC4-6F175D3DCCD1}">
-                  <a14:hiddenFill xmlns:a14="http://schemas.microsoft.com/office/drawing/2010/main" xmlns="">
+                  <a14:hiddenFill xmlns="" xmlns:a14="http://schemas.microsoft.com/office/drawing/2010/main">
                     <a:solidFill>
                       <a:srgbClr val="FFFFFF"/>
                     </a:solidFill>
                   </a14:hiddenFill>
                 </a:ext>
                 <a:ext uri="{91240B29-F687-4f45-9708-019B960494DF}">
-                  <a14:hiddenLine xmlns:a14="http://schemas.microsoft.com/office/drawing/2010/main" xmlns="" w="12700">
+                  <a14:hiddenLine xmlns="" xmlns:a14="http://schemas.microsoft.com/office/drawing/2010/main" w="12700">
                     <a:solidFill>
                       <a:srgbClr val="000000"/>
                     </a:solidFill>
@@ -30777,14 +30780,14 @@
           <a:noFill/>
           <a:extLst>
             <a:ext uri="{909E8E84-426E-40dd-AFC4-6F175D3DCCD1}">
-              <a14:hiddenFill xmlns="" xmlns:a14="http://schemas.microsoft.com/office/drawing/2010/main">
+              <a14:hiddenFill xmlns:a14="http://schemas.microsoft.com/office/drawing/2010/main" xmlns="">
                 <a:solidFill>
                   <a:srgbClr val="FFFFFF"/>
                 </a:solidFill>
               </a14:hiddenFill>
             </a:ext>
             <a:ext uri="{91240B29-F687-4f45-9708-019B960494DF}">
-              <a14:hiddenLine xmlns="" xmlns:a14="http://schemas.microsoft.com/office/drawing/2010/main" w="9525">
+              <a14:hiddenLine xmlns:a14="http://schemas.microsoft.com/office/drawing/2010/main" xmlns="" w="9525">
                 <a:solidFill>
                   <a:srgbClr val="000000"/>
                 </a:solidFill>
@@ -31554,14 +31557,14 @@
           <a:noFill/>
           <a:extLst>
             <a:ext uri="{909E8E84-426E-40dd-AFC4-6F175D3DCCD1}">
-              <a14:hiddenFill xmlns="" xmlns:a14="http://schemas.microsoft.com/office/drawing/2010/main">
+              <a14:hiddenFill xmlns:a14="http://schemas.microsoft.com/office/drawing/2010/main" xmlns="">
                 <a:solidFill>
                   <a:srgbClr val="FFFFFF"/>
                 </a:solidFill>
               </a14:hiddenFill>
             </a:ext>
             <a:ext uri="{91240B29-F687-4f45-9708-019B960494DF}">
-              <a14:hiddenLine xmlns="" xmlns:a14="http://schemas.microsoft.com/office/drawing/2010/main" w="9525">
+              <a14:hiddenLine xmlns:a14="http://schemas.microsoft.com/office/drawing/2010/main" xmlns="" w="9525">
                 <a:solidFill>
                   <a:srgbClr val="000000"/>
                 </a:solidFill>
@@ -31865,14 +31868,14 @@
           <a:noFill/>
           <a:extLst>
             <a:ext uri="{909E8E84-426E-40dd-AFC4-6F175D3DCCD1}">
-              <a14:hiddenFill xmlns="" xmlns:a14="http://schemas.microsoft.com/office/drawing/2010/main">
+              <a14:hiddenFill xmlns:a14="http://schemas.microsoft.com/office/drawing/2010/main" xmlns="">
                 <a:solidFill>
                   <a:srgbClr val="FFFFFF"/>
                 </a:solidFill>
               </a14:hiddenFill>
             </a:ext>
             <a:ext uri="{91240B29-F687-4f45-9708-019B960494DF}">
-              <a14:hiddenLine xmlns="" xmlns:a14="http://schemas.microsoft.com/office/drawing/2010/main" w="9525">
+              <a14:hiddenLine xmlns:a14="http://schemas.microsoft.com/office/drawing/2010/main" xmlns="" w="9525">
                 <a:solidFill>
                   <a:srgbClr val="000000"/>
                 </a:solidFill>
@@ -32268,14 +32271,14 @@
           <a:noFill/>
           <a:extLst>
             <a:ext uri="{909E8E84-426E-40dd-AFC4-6F175D3DCCD1}">
-              <a14:hiddenFill xmlns="" xmlns:a14="http://schemas.microsoft.com/office/drawing/2010/main">
+              <a14:hiddenFill xmlns:a14="http://schemas.microsoft.com/office/drawing/2010/main" xmlns="">
                 <a:solidFill>
                   <a:srgbClr val="FFFFFF"/>
                 </a:solidFill>
               </a14:hiddenFill>
             </a:ext>
             <a:ext uri="{91240B29-F687-4f45-9708-019B960494DF}">
-              <a14:hiddenLine xmlns="" xmlns:a14="http://schemas.microsoft.com/office/drawing/2010/main" w="9525">
+              <a14:hiddenLine xmlns:a14="http://schemas.microsoft.com/office/drawing/2010/main" xmlns="" w="9525">
                 <a:solidFill>
                   <a:srgbClr val="000000"/>
                 </a:solidFill>
@@ -32704,14 +32707,14 @@
           <a:noFill/>
           <a:extLst>
             <a:ext uri="{909E8E84-426E-40dd-AFC4-6F175D3DCCD1}">
-              <a14:hiddenFill xmlns="" xmlns:a14="http://schemas.microsoft.com/office/drawing/2010/main">
+              <a14:hiddenFill xmlns:a14="http://schemas.microsoft.com/office/drawing/2010/main" xmlns="">
                 <a:solidFill>
                   <a:srgbClr val="FFFFFF"/>
                 </a:solidFill>
               </a14:hiddenFill>
             </a:ext>
             <a:ext uri="{91240B29-F687-4f45-9708-019B960494DF}">
-              <a14:hiddenLine xmlns="" xmlns:a14="http://schemas.microsoft.com/office/drawing/2010/main" w="9525">
+              <a14:hiddenLine xmlns:a14="http://schemas.microsoft.com/office/drawing/2010/main" xmlns="" w="9525">
                 <a:solidFill>
                   <a:srgbClr val="000000"/>
                 </a:solidFill>
@@ -33140,14 +33143,14 @@
           <a:noFill/>
           <a:extLst>
             <a:ext uri="{909E8E84-426E-40dd-AFC4-6F175D3DCCD1}">
-              <a14:hiddenFill xmlns="" xmlns:a14="http://schemas.microsoft.com/office/drawing/2010/main">
+              <a14:hiddenFill xmlns:a14="http://schemas.microsoft.com/office/drawing/2010/main" xmlns="">
                 <a:solidFill>
                   <a:srgbClr val="FFFFFF"/>
                 </a:solidFill>
               </a14:hiddenFill>
             </a:ext>
             <a:ext uri="{91240B29-F687-4f45-9708-019B960494DF}">
-              <a14:hiddenLine xmlns="" xmlns:a14="http://schemas.microsoft.com/office/drawing/2010/main" w="9525">
+              <a14:hiddenLine xmlns:a14="http://schemas.microsoft.com/office/drawing/2010/main" xmlns="" w="9525">
                 <a:solidFill>
                   <a:srgbClr val="000000"/>
                 </a:solidFill>
@@ -33653,14 +33656,14 @@
           <a:noFill/>
           <a:extLst>
             <a:ext uri="{909E8E84-426E-40dd-AFC4-6F175D3DCCD1}">
-              <a14:hiddenFill xmlns="" xmlns:a14="http://schemas.microsoft.com/office/drawing/2010/main">
+              <a14:hiddenFill xmlns:a14="http://schemas.microsoft.com/office/drawing/2010/main" xmlns="">
                 <a:solidFill>
                   <a:srgbClr val="FFFFFF"/>
                 </a:solidFill>
               </a14:hiddenFill>
             </a:ext>
             <a:ext uri="{91240B29-F687-4f45-9708-019B960494DF}">
-              <a14:hiddenLine xmlns="" xmlns:a14="http://schemas.microsoft.com/office/drawing/2010/main" w="9525">
+              <a14:hiddenLine xmlns:a14="http://schemas.microsoft.com/office/drawing/2010/main" xmlns="" w="9525">
                 <a:solidFill>
                   <a:srgbClr val="000000"/>
                 </a:solidFill>
@@ -34194,14 +34197,14 @@
           <a:noFill/>
           <a:extLst>
             <a:ext uri="{909E8E84-426E-40dd-AFC4-6F175D3DCCD1}">
-              <a14:hiddenFill xmlns="" xmlns:a14="http://schemas.microsoft.com/office/drawing/2010/main">
+              <a14:hiddenFill xmlns:a14="http://schemas.microsoft.com/office/drawing/2010/main" xmlns="">
                 <a:solidFill>
                   <a:srgbClr val="FFFFFF"/>
                 </a:solidFill>
               </a14:hiddenFill>
             </a:ext>
             <a:ext uri="{91240B29-F687-4f45-9708-019B960494DF}">
-              <a14:hiddenLine xmlns="" xmlns:a14="http://schemas.microsoft.com/office/drawing/2010/main" w="9525">
+              <a14:hiddenLine xmlns:a14="http://schemas.microsoft.com/office/drawing/2010/main" xmlns="" w="9525">
                 <a:solidFill>
                   <a:srgbClr val="000000"/>
                 </a:solidFill>
@@ -34735,14 +34738,14 @@
           <a:noFill/>
           <a:extLst>
             <a:ext uri="{909E8E84-426E-40dd-AFC4-6F175D3DCCD1}">
-              <a14:hiddenFill xmlns="" xmlns:a14="http://schemas.microsoft.com/office/drawing/2010/main">
+              <a14:hiddenFill xmlns:a14="http://schemas.microsoft.com/office/drawing/2010/main" xmlns="">
                 <a:solidFill>
                   <a:srgbClr val="FFFFFF"/>
                 </a:solidFill>
               </a14:hiddenFill>
             </a:ext>
             <a:ext uri="{91240B29-F687-4f45-9708-019B960494DF}">
-              <a14:hiddenLine xmlns="" xmlns:a14="http://schemas.microsoft.com/office/drawing/2010/main" w="9525">
+              <a14:hiddenLine xmlns:a14="http://schemas.microsoft.com/office/drawing/2010/main" xmlns="" w="9525">
                 <a:solidFill>
                   <a:srgbClr val="000000"/>
                 </a:solidFill>
@@ -35390,14 +35393,14 @@
           <a:noFill/>
           <a:extLst>
             <a:ext uri="{909E8E84-426E-40dd-AFC4-6F175D3DCCD1}">
-              <a14:hiddenFill xmlns="" xmlns:a14="http://schemas.microsoft.com/office/drawing/2010/main">
+              <a14:hiddenFill xmlns:a14="http://schemas.microsoft.com/office/drawing/2010/main" xmlns="">
                 <a:solidFill>
                   <a:srgbClr val="FFFFFF"/>
                 </a:solidFill>
               </a14:hiddenFill>
             </a:ext>
             <a:ext uri="{91240B29-F687-4f45-9708-019B960494DF}">
-              <a14:hiddenLine xmlns="" xmlns:a14="http://schemas.microsoft.com/office/drawing/2010/main" w="9525">
+              <a14:hiddenLine xmlns:a14="http://schemas.microsoft.com/office/drawing/2010/main" xmlns="" w="9525">
                 <a:solidFill>
                   <a:srgbClr val="000000"/>
                 </a:solidFill>
@@ -36045,14 +36048,14 @@
           <a:noFill/>
           <a:extLst>
             <a:ext uri="{909E8E84-426E-40dd-AFC4-6F175D3DCCD1}">
-              <a14:hiddenFill xmlns="" xmlns:a14="http://schemas.microsoft.com/office/drawing/2010/main">
+              <a14:hiddenFill xmlns:a14="http://schemas.microsoft.com/office/drawing/2010/main" xmlns="">
                 <a:solidFill>
                   <a:srgbClr val="FFFFFF"/>
                 </a:solidFill>
               </a14:hiddenFill>
             </a:ext>
             <a:ext uri="{91240B29-F687-4f45-9708-019B960494DF}">
-              <a14:hiddenLine xmlns="" xmlns:a14="http://schemas.microsoft.com/office/drawing/2010/main" w="9525">
+              <a14:hiddenLine xmlns:a14="http://schemas.microsoft.com/office/drawing/2010/main" xmlns="" w="9525">
                 <a:solidFill>
                   <a:srgbClr val="000000"/>
                 </a:solidFill>
@@ -36990,14 +36993,14 @@
           <a:noFill/>
           <a:extLst>
             <a:ext uri="{909E8E84-426E-40dd-AFC4-6F175D3DCCD1}">
-              <a14:hiddenFill xmlns="" xmlns:a14="http://schemas.microsoft.com/office/drawing/2010/main">
+              <a14:hiddenFill xmlns:a14="http://schemas.microsoft.com/office/drawing/2010/main" xmlns="">
                 <a:solidFill>
                   <a:srgbClr val="FFFFFF"/>
                 </a:solidFill>
               </a14:hiddenFill>
             </a:ext>
             <a:ext uri="{91240B29-F687-4f45-9708-019B960494DF}">
-              <a14:hiddenLine xmlns="" xmlns:a14="http://schemas.microsoft.com/office/drawing/2010/main" w="9525">
+              <a14:hiddenLine xmlns:a14="http://schemas.microsoft.com/office/drawing/2010/main" xmlns="" w="9525">
                 <a:solidFill>
                   <a:srgbClr val="000000"/>
                 </a:solidFill>

</xml_diff>